<commit_message>
docs: update Round 1 presentation deck
</commit_message>
<xml_diff>
--- a/docs/DATATHON-Round1-Idea-PPT-CarePing.pptx
+++ b/docs/DATATHON-Round1-Idea-PPT-CarePing.pptx
@@ -5,16 +5,16 @@
     <p:sldMasterId id="2147483648" r:id="rId1"/>
   </p:sldMasterIdLst>
   <p:sldIdLst>
-    <p:sldId id="256" r:id="rId7"/>
-    <p:sldId id="257" r:id="rId8"/>
-    <p:sldId id="258" r:id="rId9"/>
-    <p:sldId id="259" r:id="rId10"/>
-    <p:sldId id="260" r:id="rId11"/>
-    <p:sldId id="261" r:id="rId12"/>
-    <p:sldId id="262" r:id="rId13"/>
-    <p:sldId id="263" r:id="rId14"/>
+    <p:sldId id="256" r:id="rId2"/>
+    <p:sldId id="257" r:id="rId3"/>
+    <p:sldId id="258" r:id="rId4"/>
+    <p:sldId id="259" r:id="rId5"/>
+    <p:sldId id="260" r:id="rId6"/>
+    <p:sldId id="261" r:id="rId7"/>
+    <p:sldId id="262" r:id="rId8"/>
+    <p:sldId id="263" r:id="rId9"/>
   </p:sldIdLst>
-  <p:sldSz cx="12191695" cy="6858000" type="screen4x3"/>
+  <p:sldSz cx="12192000" cy="6858000"/>
   <p:notesSz cx="6858000" cy="9144000"/>
   <p:defaultTextStyle>
     <a:defPPr>
@@ -111,6 +111,22 @@
       </a:defRPr>
     </a:lvl9pPr>
   </p:defaultTextStyle>
+  <p:extLst>
+    <p:ext uri="{EFAFB233-063F-42B5-8137-9DF3F51BA10A}">
+      <p15:sldGuideLst xmlns:p15="http://schemas.microsoft.com/office/powerpoint/2012/main">
+        <p15:guide id="1" orient="horz" pos="2160">
+          <p15:clr>
+            <a:srgbClr val="A4A3A4"/>
+          </p15:clr>
+        </p15:guide>
+        <p15:guide id="2" pos="2880">
+          <p15:clr>
+            <a:srgbClr val="A4A3A4"/>
+          </p15:clr>
+        </p15:guide>
+      </p15:sldGuideLst>
+    </p:ext>
+  </p:extLst>
 </p:presentation>
 </file>
 
@@ -152,10 +168,9 @@
           <a:lstStyle/>
           <a:p>
             <a:r>
-              <a:rPr lang="en-US" smtClean="0"/>
+              <a:rPr lang="en-US"/>
               <a:t>Click to edit Master title style</a:t>
             </a:r>
-            <a:endParaRPr lang="en-US"/>
           </a:p>
         </p:txBody>
       </p:sp>
@@ -271,10 +286,9 @@
           </a:lstStyle>
           <a:p>
             <a:r>
-              <a:rPr lang="en-US" smtClean="0"/>
+              <a:rPr lang="en-US"/>
               <a:t>Click to edit Master subtitle style</a:t>
             </a:r>
-            <a:endParaRPr lang="en-US"/>
           </a:p>
         </p:txBody>
       </p:sp>
@@ -295,7 +309,7 @@
           <a:p>
             <a:fld id="{5BCAD085-E8A6-8845-BD4E-CB4CCA059FC4}" type="datetimeFigureOut">
               <a:rPr lang="en-US" smtClean="0"/>
-              <a:t>1/27/13</a:t>
+              <a:t>10/16/2026</a:t>
             </a:fld>
             <a:endParaRPr lang="en-US"/>
           </a:p>
@@ -389,10 +403,9 @@
           <a:lstStyle/>
           <a:p>
             <a:r>
-              <a:rPr lang="en-US" smtClean="0"/>
+              <a:rPr lang="en-US"/>
               <a:t>Click to edit Master title style</a:t>
             </a:r>
-            <a:endParaRPr lang="en-US"/>
           </a:p>
         </p:txBody>
       </p:sp>
@@ -413,38 +426,37 @@
           <a:p>
             <a:pPr lvl="0"/>
             <a:r>
-              <a:rPr lang="en-US" smtClean="0"/>
+              <a:rPr lang="en-US"/>
               <a:t>Click to edit Master text styles</a:t>
             </a:r>
           </a:p>
           <a:p>
             <a:pPr lvl="1"/>
             <a:r>
-              <a:rPr lang="en-US" smtClean="0"/>
+              <a:rPr lang="en-US"/>
               <a:t>Second level</a:t>
             </a:r>
           </a:p>
           <a:p>
             <a:pPr lvl="2"/>
             <a:r>
-              <a:rPr lang="en-US" smtClean="0"/>
+              <a:rPr lang="en-US"/>
               <a:t>Third level</a:t>
             </a:r>
           </a:p>
           <a:p>
             <a:pPr lvl="3"/>
             <a:r>
-              <a:rPr lang="en-US" smtClean="0"/>
+              <a:rPr lang="en-US"/>
               <a:t>Fourth level</a:t>
             </a:r>
           </a:p>
           <a:p>
             <a:pPr lvl="4"/>
             <a:r>
-              <a:rPr lang="en-US" smtClean="0"/>
+              <a:rPr lang="en-US"/>
               <a:t>Fifth level</a:t>
             </a:r>
-            <a:endParaRPr lang="en-US"/>
           </a:p>
         </p:txBody>
       </p:sp>
@@ -465,7 +477,7 @@
           <a:p>
             <a:fld id="{5BCAD085-E8A6-8845-BD4E-CB4CCA059FC4}" type="datetimeFigureOut">
               <a:rPr lang="en-US" smtClean="0"/>
-              <a:t>1/27/13</a:t>
+              <a:t>10/16/2026</a:t>
             </a:fld>
             <a:endParaRPr lang="en-US"/>
           </a:p>
@@ -564,10 +576,9 @@
           <a:lstStyle/>
           <a:p>
             <a:r>
-              <a:rPr lang="en-US" smtClean="0"/>
+              <a:rPr lang="en-US"/>
               <a:t>Click to edit Master title style</a:t>
             </a:r>
-            <a:endParaRPr lang="en-US"/>
           </a:p>
         </p:txBody>
       </p:sp>
@@ -593,38 +604,37 @@
           <a:p>
             <a:pPr lvl="0"/>
             <a:r>
-              <a:rPr lang="en-US" smtClean="0"/>
+              <a:rPr lang="en-US"/>
               <a:t>Click to edit Master text styles</a:t>
             </a:r>
           </a:p>
           <a:p>
             <a:pPr lvl="1"/>
             <a:r>
-              <a:rPr lang="en-US" smtClean="0"/>
+              <a:rPr lang="en-US"/>
               <a:t>Second level</a:t>
             </a:r>
           </a:p>
           <a:p>
             <a:pPr lvl="2"/>
             <a:r>
-              <a:rPr lang="en-US" smtClean="0"/>
+              <a:rPr lang="en-US"/>
               <a:t>Third level</a:t>
             </a:r>
           </a:p>
           <a:p>
             <a:pPr lvl="3"/>
             <a:r>
-              <a:rPr lang="en-US" smtClean="0"/>
+              <a:rPr lang="en-US"/>
               <a:t>Fourth level</a:t>
             </a:r>
           </a:p>
           <a:p>
             <a:pPr lvl="4"/>
             <a:r>
-              <a:rPr lang="en-US" smtClean="0"/>
+              <a:rPr lang="en-US"/>
               <a:t>Fifth level</a:t>
             </a:r>
-            <a:endParaRPr lang="en-US"/>
           </a:p>
         </p:txBody>
       </p:sp>
@@ -645,7 +655,7 @@
           <a:p>
             <a:fld id="{5BCAD085-E8A6-8845-BD4E-CB4CCA059FC4}" type="datetimeFigureOut">
               <a:rPr lang="en-US" smtClean="0"/>
-              <a:t>1/27/13</a:t>
+              <a:t>10/16/2026</a:t>
             </a:fld>
             <a:endParaRPr lang="en-US"/>
           </a:p>
@@ -739,10 +749,9 @@
           <a:lstStyle/>
           <a:p>
             <a:r>
-              <a:rPr lang="en-US" smtClean="0"/>
+              <a:rPr lang="en-US"/>
               <a:t>Click to edit Master title style</a:t>
             </a:r>
-            <a:endParaRPr lang="en-US"/>
           </a:p>
         </p:txBody>
       </p:sp>
@@ -763,38 +772,37 @@
           <a:p>
             <a:pPr lvl="0"/>
             <a:r>
-              <a:rPr lang="en-US" smtClean="0"/>
+              <a:rPr lang="en-US"/>
               <a:t>Click to edit Master text styles</a:t>
             </a:r>
           </a:p>
           <a:p>
             <a:pPr lvl="1"/>
             <a:r>
-              <a:rPr lang="en-US" smtClean="0"/>
+              <a:rPr lang="en-US"/>
               <a:t>Second level</a:t>
             </a:r>
           </a:p>
           <a:p>
             <a:pPr lvl="2"/>
             <a:r>
-              <a:rPr lang="en-US" smtClean="0"/>
+              <a:rPr lang="en-US"/>
               <a:t>Third level</a:t>
             </a:r>
           </a:p>
           <a:p>
             <a:pPr lvl="3"/>
             <a:r>
-              <a:rPr lang="en-US" smtClean="0"/>
+              <a:rPr lang="en-US"/>
               <a:t>Fourth level</a:t>
             </a:r>
           </a:p>
           <a:p>
             <a:pPr lvl="4"/>
             <a:r>
-              <a:rPr lang="en-US" smtClean="0"/>
+              <a:rPr lang="en-US"/>
               <a:t>Fifth level</a:t>
             </a:r>
-            <a:endParaRPr lang="en-US"/>
           </a:p>
         </p:txBody>
       </p:sp>
@@ -815,7 +823,7 @@
           <a:p>
             <a:fld id="{5BCAD085-E8A6-8845-BD4E-CB4CCA059FC4}" type="datetimeFigureOut">
               <a:rPr lang="en-US" smtClean="0"/>
-              <a:t>1/27/13</a:t>
+              <a:t>10/16/2026</a:t>
             </a:fld>
             <a:endParaRPr lang="en-US"/>
           </a:p>
@@ -918,10 +926,9 @@
           </a:lstStyle>
           <a:p>
             <a:r>
-              <a:rPr lang="en-US" smtClean="0"/>
+              <a:rPr lang="en-US"/>
               <a:t>Click to edit Master title style</a:t>
             </a:r>
-            <a:endParaRPr lang="en-US"/>
           </a:p>
         </p:txBody>
       </p:sp>
@@ -1038,7 +1045,7 @@
           <a:p>
             <a:pPr lvl="0"/>
             <a:r>
-              <a:rPr lang="en-US" smtClean="0"/>
+              <a:rPr lang="en-US"/>
               <a:t>Click to edit Master text styles</a:t>
             </a:r>
           </a:p>
@@ -1061,7 +1068,7 @@
           <a:p>
             <a:fld id="{5BCAD085-E8A6-8845-BD4E-CB4CCA059FC4}" type="datetimeFigureOut">
               <a:rPr lang="en-US" smtClean="0"/>
-              <a:t>1/27/13</a:t>
+              <a:t>10/16/2026</a:t>
             </a:fld>
             <a:endParaRPr lang="en-US"/>
           </a:p>
@@ -1155,10 +1162,9 @@
           <a:lstStyle/>
           <a:p>
             <a:r>
-              <a:rPr lang="en-US" smtClean="0"/>
+              <a:rPr lang="en-US"/>
               <a:t>Click to edit Master title style</a:t>
             </a:r>
-            <a:endParaRPr lang="en-US"/>
           </a:p>
         </p:txBody>
       </p:sp>
@@ -1212,38 +1218,37 @@
           <a:p>
             <a:pPr lvl="0"/>
             <a:r>
-              <a:rPr lang="en-US" smtClean="0"/>
+              <a:rPr lang="en-US"/>
               <a:t>Click to edit Master text styles</a:t>
             </a:r>
           </a:p>
           <a:p>
             <a:pPr lvl="1"/>
             <a:r>
-              <a:rPr lang="en-US" smtClean="0"/>
+              <a:rPr lang="en-US"/>
               <a:t>Second level</a:t>
             </a:r>
           </a:p>
           <a:p>
             <a:pPr lvl="2"/>
             <a:r>
-              <a:rPr lang="en-US" smtClean="0"/>
+              <a:rPr lang="en-US"/>
               <a:t>Third level</a:t>
             </a:r>
           </a:p>
           <a:p>
             <a:pPr lvl="3"/>
             <a:r>
-              <a:rPr lang="en-US" smtClean="0"/>
+              <a:rPr lang="en-US"/>
               <a:t>Fourth level</a:t>
             </a:r>
           </a:p>
           <a:p>
             <a:pPr lvl="4"/>
             <a:r>
-              <a:rPr lang="en-US" smtClean="0"/>
+              <a:rPr lang="en-US"/>
               <a:t>Fifth level</a:t>
             </a:r>
-            <a:endParaRPr lang="en-US"/>
           </a:p>
         </p:txBody>
       </p:sp>
@@ -1297,38 +1302,37 @@
           <a:p>
             <a:pPr lvl="0"/>
             <a:r>
-              <a:rPr lang="en-US" smtClean="0"/>
+              <a:rPr lang="en-US"/>
               <a:t>Click to edit Master text styles</a:t>
             </a:r>
           </a:p>
           <a:p>
             <a:pPr lvl="1"/>
             <a:r>
-              <a:rPr lang="en-US" smtClean="0"/>
+              <a:rPr lang="en-US"/>
               <a:t>Second level</a:t>
             </a:r>
           </a:p>
           <a:p>
             <a:pPr lvl="2"/>
             <a:r>
-              <a:rPr lang="en-US" smtClean="0"/>
+              <a:rPr lang="en-US"/>
               <a:t>Third level</a:t>
             </a:r>
           </a:p>
           <a:p>
             <a:pPr lvl="3"/>
             <a:r>
-              <a:rPr lang="en-US" smtClean="0"/>
+              <a:rPr lang="en-US"/>
               <a:t>Fourth level</a:t>
             </a:r>
           </a:p>
           <a:p>
             <a:pPr lvl="4"/>
             <a:r>
-              <a:rPr lang="en-US" smtClean="0"/>
+              <a:rPr lang="en-US"/>
               <a:t>Fifth level</a:t>
             </a:r>
-            <a:endParaRPr lang="en-US"/>
           </a:p>
         </p:txBody>
       </p:sp>
@@ -1349,7 +1353,7 @@
           <a:p>
             <a:fld id="{5BCAD085-E8A6-8845-BD4E-CB4CCA059FC4}" type="datetimeFigureOut">
               <a:rPr lang="en-US" smtClean="0"/>
-              <a:t>1/27/13</a:t>
+              <a:t>10/16/2026</a:t>
             </a:fld>
             <a:endParaRPr lang="en-US"/>
           </a:p>
@@ -1447,10 +1451,9 @@
           </a:lstStyle>
           <a:p>
             <a:r>
-              <a:rPr lang="en-US" smtClean="0"/>
+              <a:rPr lang="en-US"/>
               <a:t>Click to edit Master title style</a:t>
             </a:r>
-            <a:endParaRPr lang="en-US"/>
           </a:p>
         </p:txBody>
       </p:sp>
@@ -1513,7 +1516,7 @@
           <a:p>
             <a:pPr lvl="0"/>
             <a:r>
-              <a:rPr lang="en-US" smtClean="0"/>
+              <a:rPr lang="en-US"/>
               <a:t>Click to edit Master text styles</a:t>
             </a:r>
           </a:p>
@@ -1569,38 +1572,37 @@
           <a:p>
             <a:pPr lvl="0"/>
             <a:r>
-              <a:rPr lang="en-US" smtClean="0"/>
+              <a:rPr lang="en-US"/>
               <a:t>Click to edit Master text styles</a:t>
             </a:r>
           </a:p>
           <a:p>
             <a:pPr lvl="1"/>
             <a:r>
-              <a:rPr lang="en-US" smtClean="0"/>
+              <a:rPr lang="en-US"/>
               <a:t>Second level</a:t>
             </a:r>
           </a:p>
           <a:p>
             <a:pPr lvl="2"/>
             <a:r>
-              <a:rPr lang="en-US" smtClean="0"/>
+              <a:rPr lang="en-US"/>
               <a:t>Third level</a:t>
             </a:r>
           </a:p>
           <a:p>
             <a:pPr lvl="3"/>
             <a:r>
-              <a:rPr lang="en-US" smtClean="0"/>
+              <a:rPr lang="en-US"/>
               <a:t>Fourth level</a:t>
             </a:r>
           </a:p>
           <a:p>
             <a:pPr lvl="4"/>
             <a:r>
-              <a:rPr lang="en-US" smtClean="0"/>
+              <a:rPr lang="en-US"/>
               <a:t>Fifth level</a:t>
             </a:r>
-            <a:endParaRPr lang="en-US"/>
           </a:p>
         </p:txBody>
       </p:sp>
@@ -1663,7 +1665,7 @@
           <a:p>
             <a:pPr lvl="0"/>
             <a:r>
-              <a:rPr lang="en-US" smtClean="0"/>
+              <a:rPr lang="en-US"/>
               <a:t>Click to edit Master text styles</a:t>
             </a:r>
           </a:p>
@@ -1719,38 +1721,37 @@
           <a:p>
             <a:pPr lvl="0"/>
             <a:r>
-              <a:rPr lang="en-US" smtClean="0"/>
+              <a:rPr lang="en-US"/>
               <a:t>Click to edit Master text styles</a:t>
             </a:r>
           </a:p>
           <a:p>
             <a:pPr lvl="1"/>
             <a:r>
-              <a:rPr lang="en-US" smtClean="0"/>
+              <a:rPr lang="en-US"/>
               <a:t>Second level</a:t>
             </a:r>
           </a:p>
           <a:p>
             <a:pPr lvl="2"/>
             <a:r>
-              <a:rPr lang="en-US" smtClean="0"/>
+              <a:rPr lang="en-US"/>
               <a:t>Third level</a:t>
             </a:r>
           </a:p>
           <a:p>
             <a:pPr lvl="3"/>
             <a:r>
-              <a:rPr lang="en-US" smtClean="0"/>
+              <a:rPr lang="en-US"/>
               <a:t>Fourth level</a:t>
             </a:r>
           </a:p>
           <a:p>
             <a:pPr lvl="4"/>
             <a:r>
-              <a:rPr lang="en-US" smtClean="0"/>
+              <a:rPr lang="en-US"/>
               <a:t>Fifth level</a:t>
             </a:r>
-            <a:endParaRPr lang="en-US"/>
           </a:p>
         </p:txBody>
       </p:sp>
@@ -1771,7 +1772,7 @@
           <a:p>
             <a:fld id="{5BCAD085-E8A6-8845-BD4E-CB4CCA059FC4}" type="datetimeFigureOut">
               <a:rPr lang="en-US" smtClean="0"/>
-              <a:t>1/27/13</a:t>
+              <a:t>10/16/2026</a:t>
             </a:fld>
             <a:endParaRPr lang="en-US"/>
           </a:p>
@@ -1865,10 +1866,9 @@
           <a:lstStyle/>
           <a:p>
             <a:r>
-              <a:rPr lang="en-US" smtClean="0"/>
+              <a:rPr lang="en-US"/>
               <a:t>Click to edit Master title style</a:t>
             </a:r>
-            <a:endParaRPr lang="en-US"/>
           </a:p>
         </p:txBody>
       </p:sp>
@@ -1889,7 +1889,7 @@
           <a:p>
             <a:fld id="{5BCAD085-E8A6-8845-BD4E-CB4CCA059FC4}" type="datetimeFigureOut">
               <a:rPr lang="en-US" smtClean="0"/>
-              <a:t>1/27/13</a:t>
+              <a:t>10/16/2026</a:t>
             </a:fld>
             <a:endParaRPr lang="en-US"/>
           </a:p>
@@ -1984,7 +1984,7 @@
           <a:p>
             <a:fld id="{5BCAD085-E8A6-8845-BD4E-CB4CCA059FC4}" type="datetimeFigureOut">
               <a:rPr lang="en-US" smtClean="0"/>
-              <a:t>1/27/13</a:t>
+              <a:t>10/16/2026</a:t>
             </a:fld>
             <a:endParaRPr lang="en-US"/>
           </a:p>
@@ -2087,10 +2087,9 @@
           </a:lstStyle>
           <a:p>
             <a:r>
-              <a:rPr lang="en-US" smtClean="0"/>
+              <a:rPr lang="en-US"/>
               <a:t>Click to edit Master title style</a:t>
             </a:r>
-            <a:endParaRPr lang="en-US"/>
           </a:p>
         </p:txBody>
       </p:sp>
@@ -2144,38 +2143,37 @@
           <a:p>
             <a:pPr lvl="0"/>
             <a:r>
-              <a:rPr lang="en-US" smtClean="0"/>
+              <a:rPr lang="en-US"/>
               <a:t>Click to edit Master text styles</a:t>
             </a:r>
           </a:p>
           <a:p>
             <a:pPr lvl="1"/>
             <a:r>
-              <a:rPr lang="en-US" smtClean="0"/>
+              <a:rPr lang="en-US"/>
               <a:t>Second level</a:t>
             </a:r>
           </a:p>
           <a:p>
             <a:pPr lvl="2"/>
             <a:r>
-              <a:rPr lang="en-US" smtClean="0"/>
+              <a:rPr lang="en-US"/>
               <a:t>Third level</a:t>
             </a:r>
           </a:p>
           <a:p>
             <a:pPr lvl="3"/>
             <a:r>
-              <a:rPr lang="en-US" smtClean="0"/>
+              <a:rPr lang="en-US"/>
               <a:t>Fourth level</a:t>
             </a:r>
           </a:p>
           <a:p>
             <a:pPr lvl="4"/>
             <a:r>
-              <a:rPr lang="en-US" smtClean="0"/>
+              <a:rPr lang="en-US"/>
               <a:t>Fifth level</a:t>
             </a:r>
-            <a:endParaRPr lang="en-US"/>
           </a:p>
         </p:txBody>
       </p:sp>
@@ -2238,7 +2236,7 @@
           <a:p>
             <a:pPr lvl="0"/>
             <a:r>
-              <a:rPr lang="en-US" smtClean="0"/>
+              <a:rPr lang="en-US"/>
               <a:t>Click to edit Master text styles</a:t>
             </a:r>
           </a:p>
@@ -2261,7 +2259,7 @@
           <a:p>
             <a:fld id="{5BCAD085-E8A6-8845-BD4E-CB4CCA059FC4}" type="datetimeFigureOut">
               <a:rPr lang="en-US" smtClean="0"/>
-              <a:t>1/27/13</a:t>
+              <a:t>10/16/2026</a:t>
             </a:fld>
             <a:endParaRPr lang="en-US"/>
           </a:p>
@@ -2364,10 +2362,9 @@
           </a:lstStyle>
           <a:p>
             <a:r>
-              <a:rPr lang="en-US" smtClean="0"/>
+              <a:rPr lang="en-US"/>
               <a:t>Click to edit Master title style</a:t>
             </a:r>
-            <a:endParaRPr lang="en-US"/>
           </a:p>
         </p:txBody>
       </p:sp>
@@ -2491,7 +2488,7 @@
           <a:p>
             <a:pPr lvl="0"/>
             <a:r>
-              <a:rPr lang="en-US" smtClean="0"/>
+              <a:rPr lang="en-US"/>
               <a:t>Click to edit Master text styles</a:t>
             </a:r>
           </a:p>
@@ -2514,7 +2511,7 @@
           <a:p>
             <a:fld id="{5BCAD085-E8A6-8845-BD4E-CB4CCA059FC4}" type="datetimeFigureOut">
               <a:rPr lang="en-US" smtClean="0"/>
-              <a:t>1/27/13</a:t>
+              <a:t>10/16/2026</a:t>
             </a:fld>
             <a:endParaRPr lang="en-US"/>
           </a:p>
@@ -2623,10 +2620,9 @@
           <a:lstStyle/>
           <a:p>
             <a:r>
-              <a:rPr lang="en-US" smtClean="0"/>
+              <a:rPr lang="en-US"/>
               <a:t>Click to edit Master title style</a:t>
             </a:r>
-            <a:endParaRPr lang="en-US"/>
           </a:p>
         </p:txBody>
       </p:sp>
@@ -2657,38 +2653,37 @@
           <a:p>
             <a:pPr lvl="0"/>
             <a:r>
-              <a:rPr lang="en-US" smtClean="0"/>
+              <a:rPr lang="en-US"/>
               <a:t>Click to edit Master text styles</a:t>
             </a:r>
           </a:p>
           <a:p>
             <a:pPr lvl="1"/>
             <a:r>
-              <a:rPr lang="en-US" smtClean="0"/>
+              <a:rPr lang="en-US"/>
               <a:t>Second level</a:t>
             </a:r>
           </a:p>
           <a:p>
             <a:pPr lvl="2"/>
             <a:r>
-              <a:rPr lang="en-US" smtClean="0"/>
+              <a:rPr lang="en-US"/>
               <a:t>Third level</a:t>
             </a:r>
           </a:p>
           <a:p>
             <a:pPr lvl="3"/>
             <a:r>
-              <a:rPr lang="en-US" smtClean="0"/>
+              <a:rPr lang="en-US"/>
               <a:t>Fourth level</a:t>
             </a:r>
           </a:p>
           <a:p>
             <a:pPr lvl="4"/>
             <a:r>
-              <a:rPr lang="en-US" smtClean="0"/>
+              <a:rPr lang="en-US"/>
               <a:t>Fifth level</a:t>
             </a:r>
-            <a:endParaRPr lang="en-US"/>
           </a:p>
         </p:txBody>
       </p:sp>
@@ -2727,7 +2722,7 @@
           <a:p>
             <a:fld id="{5BCAD085-E8A6-8845-BD4E-CB4CCA059FC4}" type="datetimeFigureOut">
               <a:rPr lang="en-US" smtClean="0"/>
-              <a:t>1/27/13</a:t>
+              <a:t>10/16/2026</a:t>
             </a:fld>
             <a:endParaRPr lang="en-US"/>
           </a:p>
@@ -3086,7 +3081,7 @@
 </file>
 
 <file path=ppt/slides/slide1.xml><?xml version="1.0" encoding="utf-8"?>
-<p:sld xmlns:a="http://schemas.openxmlformats.org/drawingml/2006/main" xmlns:p="http://schemas.openxmlformats.org/presentationml/2006/main" xmlns:r="http://schemas.openxmlformats.org/officeDocument/2006/relationships">
+<p:sld xmlns:a="http://schemas.openxmlformats.org/drawingml/2006/main" xmlns:r="http://schemas.openxmlformats.org/officeDocument/2006/relationships" xmlns:p="http://schemas.openxmlformats.org/presentationml/2006/main">
   <p:cSld>
     <p:bg>
       <p:bgPr>
@@ -3102,7 +3097,14 @@
         <p:cNvGrpSpPr/>
         <p:nvPr/>
       </p:nvGrpSpPr>
-      <p:grpSpPr/>
+      <p:grpSpPr>
+        <a:xfrm>
+          <a:off x="0" y="0"/>
+          <a:ext cx="0" cy="0"/>
+          <a:chOff x="0" y="0"/>
+          <a:chExt cx="0" cy="0"/>
+        </a:xfrm>
+      </p:grpSpPr>
       <p:pic>
         <p:nvPicPr>
           <p:cNvPr id="2" name="Picture 1" descr="logo-dsc-light.png"/>
@@ -3216,6 +3218,7 @@
           <a:lstStyle/>
           <a:p>
             <a:pPr algn="ctr"/>
+            <a:endParaRPr/>
           </a:p>
         </p:txBody>
       </p:sp>
@@ -3315,8 +3318,8 @@
         </p:nvSpPr>
         <p:spPr>
           <a:xfrm>
-            <a:off x="2926080" y="3566160"/>
-            <a:ext cx="7772400" cy="2743200"/>
+            <a:off x="2345977" y="3520441"/>
+            <a:ext cx="7772400" cy="2872581"/>
           </a:xfrm>
           <a:prstGeom prst="rect">
             <a:avLst/>
@@ -3337,7 +3340,7 @@
               <a:buChar char="•"/>
             </a:pPr>
             <a:r>
-              <a:rPr sz="1700" b="1">
+              <a:rPr sz="2000" b="1" dirty="0">
                 <a:solidFill>
                   <a:srgbClr val="0F172A"/>
                 </a:solidFill>
@@ -3346,14 +3349,29 @@
               <a:t>Team Name: </a:t>
             </a:r>
             <a:r>
-              <a:rPr sz="1700" b="1">
+              <a:rPr sz="2000" b="1" dirty="0">
                 <a:solidFill>
                   <a:srgbClr val="0D9488"/>
                 </a:solidFill>
                 <a:latin typeface="Arial"/>
               </a:rPr>
-              <a:t>AAdharsha Kutumbam</a:t>
-            </a:r>
+              <a:t>AAdharsha </a:t>
+            </a:r>
+            <a:r>
+              <a:rPr sz="2000" b="1" dirty="0" err="1">
+                <a:solidFill>
+                  <a:srgbClr val="0D9488"/>
+                </a:solidFill>
+                <a:latin typeface="Arial"/>
+              </a:rPr>
+              <a:t>Kutumbam</a:t>
+            </a:r>
+            <a:endParaRPr sz="2000" b="1" dirty="0">
+              <a:solidFill>
+                <a:srgbClr val="0D9488"/>
+              </a:solidFill>
+              <a:latin typeface="Arial"/>
+            </a:endParaRPr>
           </a:p>
           <a:p>
             <a:pPr marL="365760" indent="-365760">
@@ -3364,7 +3382,7 @@
               <a:buChar char="•"/>
             </a:pPr>
             <a:r>
-              <a:rPr sz="1700" b="1">
+              <a:rPr sz="2000" b="1" dirty="0">
                 <a:solidFill>
                   <a:srgbClr val="0F172A"/>
                 </a:solidFill>
@@ -3373,13 +3391,31 @@
               <a:t>Team Members: </a:t>
             </a:r>
             <a:r>
-              <a:rPr sz="1700" b="0">
+              <a:rPr sz="2000" b="0" dirty="0">
                 <a:solidFill>
                   <a:srgbClr val="475569"/>
                 </a:solidFill>
                 <a:latin typeface="Arial"/>
               </a:rPr>
-              <a:t>Naga Adithya V (23BCE9062), Harsha Vardhan Vurtha (23BCE9129)</a:t>
+              <a:t>Naga Adithya V (23BCE9062), Harsha Vardhan </a:t>
+            </a:r>
+            <a:r>
+              <a:rPr sz="2000" b="0" dirty="0" err="1">
+                <a:solidFill>
+                  <a:srgbClr val="475569"/>
+                </a:solidFill>
+                <a:latin typeface="Arial"/>
+              </a:rPr>
+              <a:t>Vurtha</a:t>
+            </a:r>
+            <a:r>
+              <a:rPr sz="2000" b="0" dirty="0">
+                <a:solidFill>
+                  <a:srgbClr val="475569"/>
+                </a:solidFill>
+                <a:latin typeface="Arial"/>
+              </a:rPr>
+              <a:t> (23BCE9129)</a:t>
             </a:r>
           </a:p>
           <a:p>
@@ -3391,7 +3427,7 @@
               <a:buChar char="•"/>
             </a:pPr>
             <a:r>
-              <a:rPr sz="1700" b="1">
+              <a:rPr sz="2000" b="1" dirty="0">
                 <a:solidFill>
                   <a:srgbClr val="0F172A"/>
                 </a:solidFill>
@@ -3400,7 +3436,7 @@
               <a:t>Track Chosen: </a:t>
             </a:r>
             <a:r>
-              <a:rPr sz="1700" b="0">
+              <a:rPr sz="2000" b="0" dirty="0">
                 <a:solidFill>
                   <a:srgbClr val="475569"/>
                 </a:solidFill>
@@ -3408,6 +3444,82 @@
               </a:rPr>
               <a:t>Track 1 — Health: The Forgotten Patient</a:t>
             </a:r>
+            <a:endParaRPr lang="en-US" sz="2000" b="0" dirty="0">
+              <a:solidFill>
+                <a:srgbClr val="475569"/>
+              </a:solidFill>
+              <a:latin typeface="Arial"/>
+            </a:endParaRPr>
+          </a:p>
+          <a:p>
+            <a:pPr marL="365760" indent="-365760" algn="ctr">
+              <a:spcAft>
+                <a:spcPts val="800"/>
+              </a:spcAft>
+              <a:buFont typeface="Arial"/>
+              <a:buChar char="•"/>
+            </a:pPr>
+            <a:r>
+              <a:rPr lang="en-US" sz="2000" b="1" dirty="0">
+                <a:solidFill>
+                  <a:srgbClr val="0F172A"/>
+                </a:solidFill>
+                <a:latin typeface="Arial"/>
+              </a:rPr>
+              <a:t>Problem Statement Title: </a:t>
+            </a:r>
+            <a:br>
+              <a:rPr lang="en-US" sz="2000" b="1" dirty="0">
+                <a:solidFill>
+                  <a:srgbClr val="0F172A"/>
+                </a:solidFill>
+                <a:latin typeface="Arial"/>
+              </a:rPr>
+            </a:br>
+            <a:r>
+              <a:rPr lang="en-US" sz="2000" b="0" dirty="0">
+                <a:solidFill>
+                  <a:srgbClr val="475569"/>
+                </a:solidFill>
+                <a:latin typeface="Arial"/>
+              </a:rPr>
+              <a:t>Health — The Forgotten Patient : </a:t>
+            </a:r>
+            <a:r>
+              <a:rPr lang="en-US" sz="2000" b="1" dirty="0">
+                <a:solidFill>
+                  <a:schemeClr val="tx1">
+                    <a:lumMod val="95000"/>
+                    <a:lumOff val="5000"/>
+                  </a:schemeClr>
+                </a:solidFill>
+                <a:latin typeface="Arial"/>
+              </a:rPr>
+              <a:t>Fixing</a:t>
+            </a:r>
+            <a:r>
+              <a:rPr lang="en-US" sz="2000" b="1" dirty="0">
+                <a:solidFill>
+                  <a:srgbClr val="475569"/>
+                </a:solidFill>
+                <a:latin typeface="Arial"/>
+              </a:rPr>
+              <a:t> </a:t>
+            </a:r>
+            <a:r>
+              <a:rPr lang="en-US" sz="2000" b="1" dirty="0">
+                <a:latin typeface="Arial" panose="020B0604020202020204" pitchFamily="34" charset="0"/>
+                <a:cs typeface="Arial" panose="020B0604020202020204" pitchFamily="34" charset="0"/>
+              </a:rPr>
+              <a:t>hospital queue starvation and patient walkouts.</a:t>
+            </a:r>
+            <a:endParaRPr lang="en-US" sz="2000" b="1" dirty="0">
+              <a:solidFill>
+                <a:srgbClr val="475569"/>
+              </a:solidFill>
+              <a:latin typeface="Arial" panose="020B0604020202020204" pitchFamily="34" charset="0"/>
+              <a:cs typeface="Arial" panose="020B0604020202020204" pitchFamily="34" charset="0"/>
+            </a:endParaRPr>
           </a:p>
           <a:p>
             <a:pPr marL="365760" indent="-365760">
@@ -3418,49 +3530,31 @@
               <a:buChar char="•"/>
             </a:pPr>
             <a:r>
-              <a:rPr sz="1700" b="1">
+              <a:rPr sz="2000" b="1" dirty="0">
                 <a:solidFill>
                   <a:srgbClr val="0F172A"/>
                 </a:solidFill>
                 <a:latin typeface="Arial"/>
               </a:rPr>
-              <a:t>Problem Statement Title: </a:t>
-            </a:r>
-            <a:r>
-              <a:rPr sz="1700" b="0">
-                <a:solidFill>
-                  <a:srgbClr val="475569"/>
-                </a:solidFill>
-                <a:latin typeface="Arial"/>
-              </a:rPr>
-              <a:t>Health — The Forgotten Patient</a:t>
-            </a:r>
-          </a:p>
-          <a:p>
-            <a:pPr marL="365760" indent="-365760">
-              <a:spcAft>
-                <a:spcPts val="800"/>
-              </a:spcAft>
-              <a:buFont typeface="Arial"/>
-              <a:buChar char="•"/>
-            </a:pPr>
-            <a:r>
-              <a:rPr sz="1700" b="1">
-                <a:solidFill>
-                  <a:srgbClr val="0F172A"/>
-                </a:solidFill>
-                <a:latin typeface="Arial"/>
-              </a:rPr>
               <a:t>Product Name: </a:t>
             </a:r>
             <a:r>
-              <a:rPr sz="1700" b="1">
+              <a:rPr sz="2000" b="1" dirty="0" err="1">
                 <a:solidFill>
                   <a:srgbClr val="0D9488"/>
                 </a:solidFill>
                 <a:latin typeface="Arial"/>
               </a:rPr>
-              <a:t>CarePing  (Never Lose a Patient in Line)</a:t>
+              <a:t>CarePing</a:t>
+            </a:r>
+            <a:r>
+              <a:rPr sz="2000" b="1" dirty="0">
+                <a:solidFill>
+                  <a:srgbClr val="0D9488"/>
+                </a:solidFill>
+                <a:latin typeface="Arial"/>
+              </a:rPr>
+              <a:t>  (Never Lose a Patient in Line)</a:t>
             </a:r>
           </a:p>
         </p:txBody>
@@ -3474,7 +3568,7 @@
 </file>
 
 <file path=ppt/slides/slide2.xml><?xml version="1.0" encoding="utf-8"?>
-<p:sld xmlns:a="http://schemas.openxmlformats.org/drawingml/2006/main" xmlns:p="http://schemas.openxmlformats.org/presentationml/2006/main" xmlns:r="http://schemas.openxmlformats.org/officeDocument/2006/relationships">
+<p:sld xmlns:a="http://schemas.openxmlformats.org/drawingml/2006/main" xmlns:r="http://schemas.openxmlformats.org/officeDocument/2006/relationships" xmlns:p="http://schemas.openxmlformats.org/presentationml/2006/main">
   <p:cSld>
     <p:bg>
       <p:bgPr>
@@ -3490,7 +3584,14 @@
         <p:cNvGrpSpPr/>
         <p:nvPr/>
       </p:nvGrpSpPr>
-      <p:grpSpPr/>
+      <p:grpSpPr>
+        <a:xfrm>
+          <a:off x="0" y="0"/>
+          <a:ext cx="0" cy="0"/>
+          <a:chOff x="0" y="0"/>
+          <a:chExt cx="0" cy="0"/>
+        </a:xfrm>
+      </p:grpSpPr>
       <p:sp>
         <p:nvSpPr>
           <p:cNvPr id="2" name="TextBox 1"/>
@@ -3615,6 +3716,7 @@
           <a:lstStyle/>
           <a:p>
             <a:pPr algn="ctr"/>
+            <a:endParaRPr/>
           </a:p>
         </p:txBody>
       </p:sp>
@@ -3712,7 +3814,7 @@
           <a:p>
             <a:pPr algn="l"/>
             <a:r>
-              <a:rPr sz="2800" b="1">
+              <a:rPr sz="2800" b="1" dirty="0">
                 <a:solidFill>
                   <a:srgbClr val="000000"/>
                 </a:solidFill>
@@ -3721,7 +3823,7 @@
               <a:t>❖ </a:t>
             </a:r>
             <a:r>
-              <a:rPr sz="2800" b="1" u="sng">
+              <a:rPr sz="2800" b="1" u="sng" dirty="0">
                 <a:solidFill>
                   <a:srgbClr val="000000"/>
                 </a:solidFill>
@@ -3741,7 +3843,7 @@
         <p:spPr>
           <a:xfrm>
             <a:off x="548640" y="2194560"/>
-            <a:ext cx="11064240" cy="1828800"/>
+            <a:ext cx="11064240" cy="3385542"/>
           </a:xfrm>
           <a:prstGeom prst="rect">
             <a:avLst/>
@@ -3757,12 +3859,9 @@
             <a:pPr marL="320040" indent="-320040" algn="l">
               <a:buFont typeface="Arial"/>
               <a:buChar char="•"/>
-              <a:spcAft>
-                <a:spcPts val="1000"/>
-              </a:spcAft>
             </a:pPr>
             <a:r>
-              <a:rPr sz="1400" b="1">
+              <a:rPr sz="2000" b="1" dirty="0">
                 <a:solidFill>
                   <a:srgbClr val="0F172A"/>
                 </a:solidFill>
@@ -3771,7 +3870,7 @@
               <a:t>Who is the user &amp; their real struggle: </a:t>
             </a:r>
             <a:r>
-              <a:rPr sz="1400" b="0">
+              <a:rPr sz="2000" b="0" dirty="0">
                 <a:solidFill>
                   <a:srgbClr val="475569"/>
                 </a:solidFill>
@@ -3784,12 +3883,9 @@
             <a:pPr marL="320040" indent="-320040" algn="l">
               <a:buFont typeface="Arial"/>
               <a:buChar char="•"/>
-              <a:spcAft>
-                <a:spcPts val="1000"/>
-              </a:spcAft>
             </a:pPr>
             <a:r>
-              <a:rPr sz="1400" b="1">
+              <a:rPr sz="2000" b="1" dirty="0">
                 <a:solidFill>
                   <a:srgbClr val="0F172A"/>
                 </a:solidFill>
@@ -3798,7 +3894,7 @@
               <a:t>Why this matters right now: </a:t>
             </a:r>
             <a:r>
-              <a:rPr sz="1400" b="0">
+              <a:rPr sz="2000" b="0" dirty="0">
                 <a:solidFill>
                   <a:srgbClr val="475569"/>
                 </a:solidFill>
@@ -3811,12 +3907,9 @@
             <a:pPr marL="320040" indent="-320040" algn="l">
               <a:buFont typeface="Arial"/>
               <a:buChar char="•"/>
-              <a:spcAft>
-                <a:spcPts val="1000"/>
-              </a:spcAft>
             </a:pPr>
             <a:r>
-              <a:rPr sz="1400" b="1">
+              <a:rPr sz="2000" b="1" dirty="0">
                 <a:solidFill>
                   <a:srgbClr val="0F172A"/>
                 </a:solidFill>
@@ -3825,7 +3918,7 @@
               <a:t>What the data proved: </a:t>
             </a:r>
             <a:r>
-              <a:rPr sz="1400" b="0">
+              <a:rPr sz="2000" b="0" dirty="0">
                 <a:solidFill>
                   <a:srgbClr val="475569"/>
                 </a:solidFill>
@@ -3845,7 +3938,7 @@
 </file>
 
 <file path=ppt/slides/slide3.xml><?xml version="1.0" encoding="utf-8"?>
-<p:sld xmlns:a="http://schemas.openxmlformats.org/drawingml/2006/main" xmlns:p="http://schemas.openxmlformats.org/presentationml/2006/main" xmlns:r="http://schemas.openxmlformats.org/officeDocument/2006/relationships">
+<p:sld xmlns:a="http://schemas.openxmlformats.org/drawingml/2006/main" xmlns:r="http://schemas.openxmlformats.org/officeDocument/2006/relationships" xmlns:p="http://schemas.openxmlformats.org/presentationml/2006/main">
   <p:cSld>
     <p:bg>
       <p:bgPr>
@@ -3861,7 +3954,14 @@
         <p:cNvGrpSpPr/>
         <p:nvPr/>
       </p:nvGrpSpPr>
-      <p:grpSpPr/>
+      <p:grpSpPr>
+        <a:xfrm>
+          <a:off x="0" y="0"/>
+          <a:ext cx="0" cy="0"/>
+          <a:chOff x="0" y="0"/>
+          <a:chExt cx="0" cy="0"/>
+        </a:xfrm>
+      </p:grpSpPr>
       <p:sp>
         <p:nvSpPr>
           <p:cNvPr id="2" name="TextBox 1"/>
@@ -3986,6 +4086,7 @@
           <a:lstStyle/>
           <a:p>
             <a:pPr algn="ctr"/>
+            <a:endParaRPr/>
           </a:p>
         </p:txBody>
       </p:sp>
@@ -4128,12 +4229,9 @@
             <a:pPr marL="320040" indent="-320040" algn="l">
               <a:buFont typeface="Arial"/>
               <a:buChar char="•"/>
-              <a:spcAft>
-                <a:spcPts val="600"/>
-              </a:spcAft>
             </a:pPr>
             <a:r>
-              <a:rPr sz="1350" b="1">
+              <a:rPr b="1">
                 <a:solidFill>
                   <a:srgbClr val="0F172A"/>
                 </a:solidFill>
@@ -4142,7 +4240,7 @@
               <a:t>CarePing Smart Queue Assistant: </a:t>
             </a:r>
             <a:r>
-              <a:rPr sz="1350" b="0">
+              <a:rPr b="0">
                 <a:solidFill>
                   <a:srgbClr val="475569"/>
                 </a:solidFill>
@@ -4155,12 +4253,9 @@
             <a:pPr marL="320040" indent="-320040" algn="l">
               <a:buFont typeface="Arial"/>
               <a:buChar char="•"/>
-              <a:spcAft>
-                <a:spcPts val="600"/>
-              </a:spcAft>
             </a:pPr>
             <a:r>
-              <a:rPr sz="1350" b="1">
+              <a:rPr b="1">
                 <a:solidFill>
                   <a:srgbClr val="0F172A"/>
                 </a:solidFill>
@@ -4169,7 +4264,7 @@
               <a:t>Closing the Care Loop: </a:t>
             </a:r>
             <a:r>
-              <a:rPr sz="1350" b="0">
+              <a:rPr b="0">
                 <a:solidFill>
                   <a:srgbClr val="475569"/>
                 </a:solidFill>
@@ -4258,12 +4353,9 @@
             <a:pPr marL="320040" indent="-320040" algn="l">
               <a:buFont typeface="Arial"/>
               <a:buChar char="•"/>
-              <a:spcAft>
-                <a:spcPts val="600"/>
-              </a:spcAft>
             </a:pPr>
             <a:r>
-              <a:rPr sz="1350" b="1">
+              <a:rPr b="1">
                 <a:solidFill>
                   <a:srgbClr val="0F172A"/>
                 </a:solidFill>
@@ -4272,7 +4364,7 @@
               <a:t>Proactive Retention over Passive Triage: </a:t>
             </a:r>
             <a:r>
-              <a:rPr sz="1350" b="0">
+              <a:rPr b="0">
                 <a:solidFill>
                   <a:srgbClr val="475569"/>
                 </a:solidFill>
@@ -4285,12 +4377,9 @@
             <a:pPr marL="320040" indent="-320040" algn="l">
               <a:buFont typeface="Arial"/>
               <a:buChar char="•"/>
-              <a:spcAft>
-                <a:spcPts val="600"/>
-              </a:spcAft>
             </a:pPr>
             <a:r>
-              <a:rPr sz="1350" b="1">
+              <a:rPr b="1">
                 <a:solidFill>
                   <a:srgbClr val="0F172A"/>
                 </a:solidFill>
@@ -4299,7 +4388,7 @@
               <a:t>Zero Equipment &amp; Zero Hiring Cost: </a:t>
             </a:r>
             <a:r>
-              <a:rPr sz="1350" b="0">
+              <a:rPr b="0">
                 <a:solidFill>
                   <a:srgbClr val="475569"/>
                 </a:solidFill>
@@ -4319,7 +4408,7 @@
 </file>
 
 <file path=ppt/slides/slide4.xml><?xml version="1.0" encoding="utf-8"?>
-<p:sld xmlns:a="http://schemas.openxmlformats.org/drawingml/2006/main" xmlns:p="http://schemas.openxmlformats.org/presentationml/2006/main" xmlns:r="http://schemas.openxmlformats.org/officeDocument/2006/relationships">
+<p:sld xmlns:a="http://schemas.openxmlformats.org/drawingml/2006/main" xmlns:r="http://schemas.openxmlformats.org/officeDocument/2006/relationships" xmlns:p="http://schemas.openxmlformats.org/presentationml/2006/main">
   <p:cSld>
     <p:bg>
       <p:bgPr>
@@ -4335,7 +4424,14 @@
         <p:cNvGrpSpPr/>
         <p:nvPr/>
       </p:nvGrpSpPr>
-      <p:grpSpPr/>
+      <p:grpSpPr>
+        <a:xfrm>
+          <a:off x="0" y="0"/>
+          <a:ext cx="0" cy="0"/>
+          <a:chOff x="0" y="0"/>
+          <a:chExt cx="0" cy="0"/>
+        </a:xfrm>
+      </p:grpSpPr>
       <p:sp>
         <p:nvSpPr>
           <p:cNvPr id="2" name="TextBox 1"/>
@@ -4460,6 +4556,7 @@
           <a:lstStyle/>
           <a:p>
             <a:pPr algn="ctr"/>
+            <a:endParaRPr/>
           </a:p>
         </p:txBody>
       </p:sp>
@@ -4586,7 +4683,7 @@
         <p:spPr>
           <a:xfrm>
             <a:off x="548640" y="2194560"/>
-            <a:ext cx="11064240" cy="1828800"/>
+            <a:ext cx="11064240" cy="3385542"/>
           </a:xfrm>
           <a:prstGeom prst="rect">
             <a:avLst/>
@@ -4602,12 +4699,9 @@
             <a:pPr marL="320040" indent="-320040" algn="l">
               <a:buFont typeface="Arial"/>
               <a:buChar char="•"/>
-              <a:spcAft>
-                <a:spcPts val="800"/>
-              </a:spcAft>
             </a:pPr>
             <a:r>
-              <a:rPr sz="1350" b="1">
+              <a:rPr sz="2000" b="1" dirty="0">
                 <a:solidFill>
                   <a:srgbClr val="0F172A"/>
                 </a:solidFill>
@@ -4616,25 +4710,76 @@
               <a:t>Relational Data Mapping: </a:t>
             </a:r>
             <a:r>
-              <a:rPr sz="1350" b="0">
+              <a:rPr sz="2000" b="0" dirty="0">
                 <a:solidFill>
                   <a:srgbClr val="475569"/>
                 </a:solidFill>
                 <a:latin typeface="Arial"/>
               </a:rPr>
-              <a:t>Linked 15,012 total records across 4 relational tables: patients (2,000) joined to encounters (8,000) via patient_id; departments (12) via department_id; and diagnostic tests (5,000) via encounter_id.</a:t>
+              <a:t>Linked 15,012 total records across 4 relational tables: patients (2,000) joined to encounters (8,000) via </a:t>
+            </a:r>
+            <a:r>
+              <a:rPr sz="2000" b="0" dirty="0" err="1">
+                <a:solidFill>
+                  <a:srgbClr val="475569"/>
+                </a:solidFill>
+                <a:latin typeface="Arial"/>
+              </a:rPr>
+              <a:t>patient_id</a:t>
+            </a:r>
+            <a:r>
+              <a:rPr sz="2000" b="0" dirty="0">
+                <a:solidFill>
+                  <a:srgbClr val="475569"/>
+                </a:solidFill>
+                <a:latin typeface="Arial"/>
+              </a:rPr>
+              <a:t>; departments (12) via </a:t>
+            </a:r>
+            <a:r>
+              <a:rPr sz="2000" b="0" dirty="0" err="1">
+                <a:solidFill>
+                  <a:srgbClr val="475569"/>
+                </a:solidFill>
+                <a:latin typeface="Arial"/>
+              </a:rPr>
+              <a:t>department_id</a:t>
+            </a:r>
+            <a:r>
+              <a:rPr sz="2000" b="0" dirty="0">
+                <a:solidFill>
+                  <a:srgbClr val="475569"/>
+                </a:solidFill>
+                <a:latin typeface="Arial"/>
+              </a:rPr>
+              <a:t>; and diagnostic tests (5,000) via </a:t>
+            </a:r>
+            <a:r>
+              <a:rPr sz="2000" b="0" dirty="0" err="1">
+                <a:solidFill>
+                  <a:srgbClr val="475569"/>
+                </a:solidFill>
+                <a:latin typeface="Arial"/>
+              </a:rPr>
+              <a:t>encounter_id</a:t>
+            </a:r>
+            <a:r>
+              <a:rPr sz="2000" b="0" dirty="0">
+                <a:solidFill>
+                  <a:srgbClr val="475569"/>
+                </a:solidFill>
+                <a:latin typeface="Arial"/>
+              </a:rPr>
+              <a:t>.</a:t>
             </a:r>
           </a:p>
           <a:p>
             <a:pPr marL="320040" indent="-320040" algn="l">
               <a:buFont typeface="Arial"/>
               <a:buChar char="•"/>
-              <a:spcAft>
-                <a:spcPts val="800"/>
-              </a:spcAft>
             </a:pPr>
             <a:r>
-              <a:rPr sz="1350" b="1">
+              <a:rPr sz="2000" b="1" dirty="0">
                 <a:solidFill>
                   <a:srgbClr val="0F172A"/>
                 </a:solidFill>
@@ -4643,25 +4788,40 @@
               <a:t>Data Cleaning &amp; Forensic Catches: </a:t>
             </a:r>
             <a:r>
-              <a:rPr sz="1350" b="0">
+              <a:rPr sz="2000" b="0" dirty="0">
                 <a:solidFill>
                   <a:srgbClr val="475569"/>
                 </a:solidFill>
                 <a:latin typeface="Arial"/>
               </a:rPr>
-              <a:t>Caught the 'None' chronic condition trap (747 healthy patients were parsed as NaN missing values by standard readers; actual null rate is 0%). Flagged that 99.96% of diagnostic tests occurred outside encounter windows and all walkouts still logged treatment durations.</a:t>
+              <a:t>Caught the 'None' chronic condition trap (747 healthy patients were parsed as </a:t>
+            </a:r>
+            <a:r>
+              <a:rPr sz="2000" b="0" dirty="0" err="1">
+                <a:solidFill>
+                  <a:srgbClr val="475569"/>
+                </a:solidFill>
+                <a:latin typeface="Arial"/>
+              </a:rPr>
+              <a:t>NaN</a:t>
+            </a:r>
+            <a:r>
+              <a:rPr sz="2000" b="0" dirty="0">
+                <a:solidFill>
+                  <a:srgbClr val="475569"/>
+                </a:solidFill>
+                <a:latin typeface="Arial"/>
+              </a:rPr>
+              <a:t> missing values by standard readers; actual null rate is 0%). Flagged that 99.96% of diagnostic tests occurred outside encounter windows and all walkouts still logged treatment durations.</a:t>
             </a:r>
           </a:p>
           <a:p>
             <a:pPr marL="320040" indent="-320040" algn="l">
               <a:buFont typeface="Arial"/>
               <a:buChar char="•"/>
-              <a:spcAft>
-                <a:spcPts val="800"/>
-              </a:spcAft>
             </a:pPr>
             <a:r>
-              <a:rPr sz="1350" b="1">
+              <a:rPr sz="2000" b="1" dirty="0">
                 <a:solidFill>
                   <a:srgbClr val="0F172A"/>
                 </a:solidFill>
@@ -4670,7 +4830,7 @@
               <a:t>Core Operational Takeaways: </a:t>
             </a:r>
             <a:r>
-              <a:rPr sz="1350" b="0">
+              <a:rPr sz="2000" b="0" dirty="0">
                 <a:solidFill>
                   <a:srgbClr val="475569"/>
                 </a:solidFill>
@@ -4690,7 +4850,7 @@
 </file>
 
 <file path=ppt/slides/slide5.xml><?xml version="1.0" encoding="utf-8"?>
-<p:sld xmlns:a="http://schemas.openxmlformats.org/drawingml/2006/main" xmlns:p="http://schemas.openxmlformats.org/presentationml/2006/main" xmlns:r="http://schemas.openxmlformats.org/officeDocument/2006/relationships">
+<p:sld xmlns:a="http://schemas.openxmlformats.org/drawingml/2006/main" xmlns:r="http://schemas.openxmlformats.org/officeDocument/2006/relationships" xmlns:p="http://schemas.openxmlformats.org/presentationml/2006/main">
   <p:cSld>
     <p:bg>
       <p:bgPr>
@@ -4706,7 +4866,14 @@
         <p:cNvGrpSpPr/>
         <p:nvPr/>
       </p:nvGrpSpPr>
-      <p:grpSpPr/>
+      <p:grpSpPr>
+        <a:xfrm>
+          <a:off x="0" y="0"/>
+          <a:ext cx="0" cy="0"/>
+          <a:chOff x="0" y="0"/>
+          <a:chExt cx="0" cy="0"/>
+        </a:xfrm>
+      </p:grpSpPr>
       <p:sp>
         <p:nvSpPr>
           <p:cNvPr id="2" name="TextBox 1"/>
@@ -4831,6 +4998,7 @@
           <a:lstStyle/>
           <a:p>
             <a:pPr algn="ctr"/>
+            <a:endParaRPr/>
           </a:p>
         </p:txBody>
       </p:sp>
@@ -4957,7 +5125,7 @@
         <p:spPr>
           <a:xfrm>
             <a:off x="548640" y="2194560"/>
-            <a:ext cx="11064240" cy="1828800"/>
+            <a:ext cx="11064240" cy="3077766"/>
           </a:xfrm>
           <a:prstGeom prst="rect">
             <a:avLst/>
@@ -4973,12 +5141,9 @@
             <a:pPr marL="320040" indent="-320040" algn="l">
               <a:buFont typeface="Arial"/>
               <a:buChar char="•"/>
-              <a:spcAft>
-                <a:spcPts val="800"/>
-              </a:spcAft>
             </a:pPr>
             <a:r>
-              <a:rPr sz="1350" b="1">
+              <a:rPr sz="2000" b="1" dirty="0">
                 <a:solidFill>
                   <a:srgbClr val="0F172A"/>
                 </a:solidFill>
@@ -4987,7 +5152,7 @@
               <a:t>In-House Statistical Engine (No Black-Box APIs): </a:t>
             </a:r>
             <a:r>
-              <a:rPr sz="1350" b="0">
+              <a:rPr sz="2000" b="0" dirty="0">
                 <a:solidFill>
                   <a:srgbClr val="475569"/>
                 </a:solidFill>
@@ -5000,12 +5165,9 @@
             <a:pPr marL="320040" indent="-320040" algn="l">
               <a:buFont typeface="Arial"/>
               <a:buChar char="•"/>
-              <a:spcAft>
-                <a:spcPts val="800"/>
-              </a:spcAft>
             </a:pPr>
             <a:r>
-              <a:rPr sz="1350" b="1">
+              <a:rPr sz="2000" b="1" dirty="0">
                 <a:solidFill>
                   <a:srgbClr val="0F172A"/>
                 </a:solidFill>
@@ -5014,7 +5176,7 @@
               <a:t>Features, Targets &amp; Performance: </a:t>
             </a:r>
             <a:r>
-              <a:rPr sz="1350" b="0">
+              <a:rPr sz="2000" b="0" dirty="0">
                 <a:solidFill>
                   <a:srgbClr val="475569"/>
                 </a:solidFill>
@@ -5027,21 +5189,36 @@
             <a:pPr marL="320040" indent="-320040" algn="l">
               <a:buFont typeface="Arial"/>
               <a:buChar char="•"/>
-              <a:spcAft>
-                <a:spcPts val="800"/>
-              </a:spcAft>
             </a:pPr>
             <a:r>
-              <a:rPr sz="1350" b="1">
+              <a:rPr sz="2000" b="1" dirty="0">
                 <a:solidFill>
                   <a:srgbClr val="0F172A"/>
                 </a:solidFill>
                 <a:latin typeface="Arial"/>
               </a:rPr>
-              <a:t>How the Output Powers CarePing: </a:t>
-            </a:r>
-            <a:r>
-              <a:rPr sz="1350" b="0">
+              <a:t>How the Output Powers </a:t>
+            </a:r>
+            <a:r>
+              <a:rPr sz="2000" b="1" dirty="0" err="1">
+                <a:solidFill>
+                  <a:srgbClr val="0F172A"/>
+                </a:solidFill>
+                <a:latin typeface="Arial"/>
+              </a:rPr>
+              <a:t>CarePing</a:t>
+            </a:r>
+            <a:r>
+              <a:rPr sz="2000" b="1" dirty="0">
+                <a:solidFill>
+                  <a:srgbClr val="0F172A"/>
+                </a:solidFill>
+                <a:latin typeface="Arial"/>
+              </a:rPr>
+              <a:t>: </a:t>
+            </a:r>
+            <a:r>
+              <a:rPr sz="2000" b="0" dirty="0">
                 <a:solidFill>
                   <a:srgbClr val="475569"/>
                 </a:solidFill>
@@ -5061,7 +5238,7 @@
 </file>
 
 <file path=ppt/slides/slide6.xml><?xml version="1.0" encoding="utf-8"?>
-<p:sld xmlns:a="http://schemas.openxmlformats.org/drawingml/2006/main" xmlns:p="http://schemas.openxmlformats.org/presentationml/2006/main" xmlns:r="http://schemas.openxmlformats.org/officeDocument/2006/relationships">
+<p:sld xmlns:a="http://schemas.openxmlformats.org/drawingml/2006/main" xmlns:r="http://schemas.openxmlformats.org/officeDocument/2006/relationships" xmlns:p="http://schemas.openxmlformats.org/presentationml/2006/main">
   <p:cSld>
     <p:bg>
       <p:bgPr>
@@ -5077,7 +5254,14 @@
         <p:cNvGrpSpPr/>
         <p:nvPr/>
       </p:nvGrpSpPr>
-      <p:grpSpPr/>
+      <p:grpSpPr>
+        <a:xfrm>
+          <a:off x="0" y="0"/>
+          <a:ext cx="0" cy="0"/>
+          <a:chOff x="0" y="0"/>
+          <a:chExt cx="0" cy="0"/>
+        </a:xfrm>
+      </p:grpSpPr>
       <p:sp>
         <p:nvSpPr>
           <p:cNvPr id="2" name="TextBox 1"/>
@@ -5202,6 +5386,7 @@
           <a:lstStyle/>
           <a:p>
             <a:pPr algn="ctr"/>
+            <a:endParaRPr/>
           </a:p>
         </p:txBody>
       </p:sp>
@@ -5328,7 +5513,7 @@
         <p:spPr>
           <a:xfrm>
             <a:off x="548640" y="2194560"/>
-            <a:ext cx="11064240" cy="914400"/>
+            <a:ext cx="11064240" cy="1308050"/>
           </a:xfrm>
           <a:prstGeom prst="rect">
             <a:avLst/>
@@ -5344,12 +5529,9 @@
             <a:pPr marL="320040" indent="-320040" algn="l">
               <a:buFont typeface="Arial"/>
               <a:buChar char="•"/>
-              <a:spcAft>
-                <a:spcPts val="500"/>
-              </a:spcAft>
             </a:pPr>
             <a:r>
-              <a:rPr sz="1300" b="1">
+              <a:rPr sz="1700" b="1" dirty="0">
                 <a:solidFill>
                   <a:srgbClr val="0F172A"/>
                 </a:solidFill>
@@ -5358,7 +5540,7 @@
               <a:t>Working Prototype (Round 1): </a:t>
             </a:r>
             <a:r>
-              <a:rPr sz="1300" b="0">
+              <a:rPr sz="1700" b="0" dirty="0">
                 <a:solidFill>
                   <a:srgbClr val="475569"/>
                 </a:solidFill>
@@ -5368,15 +5550,12 @@
             </a:r>
           </a:p>
           <a:p>
-            <a:pPr algn="l" marL="320040" indent="-320040">
+            <a:pPr marL="320040" indent="-320040" algn="l">
               <a:buFont typeface="Arial"/>
               <a:buChar char="•"/>
-              <a:spcAft>
-                <a:spcPts val="500"/>
-              </a:spcAft>
             </a:pPr>
             <a:r>
-              <a:rPr sz="1300" b="1">
+              <a:rPr sz="1700" b="1" dirty="0">
                 <a:solidFill>
                   <a:srgbClr val="0F172A"/>
                 </a:solidFill>
@@ -5385,7 +5564,7 @@
               <a:t>Analytical Evidence &amp; Report: </a:t>
             </a:r>
             <a:r>
-              <a:rPr sz="1300" b="0">
+              <a:rPr sz="1700" b="0" dirty="0">
                 <a:solidFill>
                   <a:srgbClr val="475569"/>
                 </a:solidFill>
@@ -5458,7 +5637,7 @@
         <p:spPr>
           <a:xfrm>
             <a:off x="548640" y="4114800"/>
-            <a:ext cx="11064240" cy="1371600"/>
+            <a:ext cx="11064240" cy="1308050"/>
           </a:xfrm>
           <a:prstGeom prst="rect">
             <a:avLst/>
@@ -5474,12 +5653,9 @@
             <a:pPr marL="320040" indent="-320040" algn="l">
               <a:buFont typeface="Arial"/>
               <a:buChar char="•"/>
-              <a:spcAft>
-                <a:spcPts val="500"/>
-              </a:spcAft>
             </a:pPr>
             <a:r>
-              <a:rPr sz="1300" b="1">
+              <a:rPr sz="1700" b="1" dirty="0">
                 <a:solidFill>
                   <a:srgbClr val="0F172A"/>
                 </a:solidFill>
@@ -5488,7 +5664,7 @@
               <a:t>Must-Have Features for Round 2: </a:t>
             </a:r>
             <a:r>
-              <a:rPr sz="1300" b="0">
+              <a:rPr sz="1700" b="0" dirty="0">
                 <a:solidFill>
                   <a:srgbClr val="475569"/>
                 </a:solidFill>
@@ -5501,12 +5677,9 @@
             <a:pPr marL="320040" indent="-320040" algn="l">
               <a:buFont typeface="Arial"/>
               <a:buChar char="•"/>
-              <a:spcAft>
-                <a:spcPts val="500"/>
-              </a:spcAft>
             </a:pPr>
             <a:r>
-              <a:rPr sz="1300" b="1">
+              <a:rPr sz="1700" b="1" dirty="0">
                 <a:solidFill>
                   <a:srgbClr val="0F172A"/>
                 </a:solidFill>
@@ -5515,13 +5688,31 @@
               <a:t>Demo Workflow (Input → Output → Action): </a:t>
             </a:r>
             <a:r>
-              <a:rPr sz="1300" b="0">
+              <a:rPr sz="1700" b="0" dirty="0">
                 <a:solidFill>
                   <a:srgbClr val="475569"/>
                 </a:solidFill>
                 <a:latin typeface="Arial"/>
               </a:rPr>
-              <a:t>1. Patient checks in at reception → 2. CarePing estimates wait time &amp; walkout risk → 3. Live countdown updates on board → 4. Ping alerts staff at 45 min for quick comfort check-in → 5. Post-care patient transitions smoothly to discharge lounge.</a:t>
+              <a:t>1. Patient checks in at reception → 2. </a:t>
+            </a:r>
+            <a:r>
+              <a:rPr sz="1700" b="0" dirty="0" err="1">
+                <a:solidFill>
+                  <a:srgbClr val="475569"/>
+                </a:solidFill>
+                <a:latin typeface="Arial"/>
+              </a:rPr>
+              <a:t>CarePing</a:t>
+            </a:r>
+            <a:r>
+              <a:rPr sz="1700" b="0" dirty="0">
+                <a:solidFill>
+                  <a:srgbClr val="475569"/>
+                </a:solidFill>
+                <a:latin typeface="Arial"/>
+              </a:rPr>
+              <a:t> estimates wait time &amp; walkout risk → 3. Live countdown updates on board → 4. Ping alerts staff at 45 min for quick comfort check-in → 5. Post-care patient transitions smoothly to discharge lounge.</a:t>
             </a:r>
           </a:p>
         </p:txBody>
@@ -5535,7 +5726,7 @@
 </file>
 
 <file path=ppt/slides/slide7.xml><?xml version="1.0" encoding="utf-8"?>
-<p:sld xmlns:a="http://schemas.openxmlformats.org/drawingml/2006/main" xmlns:p="http://schemas.openxmlformats.org/presentationml/2006/main" xmlns:r="http://schemas.openxmlformats.org/officeDocument/2006/relationships">
+<p:sld xmlns:a="http://schemas.openxmlformats.org/drawingml/2006/main" xmlns:r="http://schemas.openxmlformats.org/officeDocument/2006/relationships" xmlns:p="http://schemas.openxmlformats.org/presentationml/2006/main">
   <p:cSld>
     <p:bg>
       <p:bgPr>
@@ -5551,7 +5742,14 @@
         <p:cNvGrpSpPr/>
         <p:nvPr/>
       </p:nvGrpSpPr>
-      <p:grpSpPr/>
+      <p:grpSpPr>
+        <a:xfrm>
+          <a:off x="0" y="0"/>
+          <a:ext cx="0" cy="0"/>
+          <a:chOff x="0" y="0"/>
+          <a:chExt cx="0" cy="0"/>
+        </a:xfrm>
+      </p:grpSpPr>
       <p:sp>
         <p:nvSpPr>
           <p:cNvPr id="2" name="TextBox 1"/>
@@ -5676,6 +5874,7 @@
           <a:lstStyle/>
           <a:p>
             <a:pPr algn="ctr"/>
+            <a:endParaRPr/>
           </a:p>
         </p:txBody>
       </p:sp>
@@ -5773,7 +5972,7 @@
           <a:p>
             <a:pPr algn="l"/>
             <a:r>
-              <a:rPr sz="2800" b="1">
+              <a:rPr sz="2800" b="1" dirty="0">
                 <a:solidFill>
                   <a:srgbClr val="000000"/>
                 </a:solidFill>
@@ -5782,7 +5981,7 @@
               <a:t>❖ </a:t>
             </a:r>
             <a:r>
-              <a:rPr sz="2800" b="1" u="sng">
+              <a:rPr sz="2800" b="1" u="sng" dirty="0">
                 <a:solidFill>
                   <a:srgbClr val="000000"/>
                 </a:solidFill>
@@ -5802,7 +6001,7 @@
         <p:spPr>
           <a:xfrm>
             <a:off x="548640" y="2194560"/>
-            <a:ext cx="11064240" cy="1371600"/>
+            <a:ext cx="11064240" cy="2769989"/>
           </a:xfrm>
           <a:prstGeom prst="rect">
             <a:avLst/>
@@ -5818,12 +6017,9 @@
             <a:pPr marL="320040" indent="-320040" algn="l">
               <a:buFont typeface="Arial"/>
               <a:buChar char="•"/>
-              <a:spcAft>
-                <a:spcPts val="1000"/>
-              </a:spcAft>
             </a:pPr>
             <a:r>
-              <a:rPr sz="1350" b="1">
+              <a:rPr sz="2000" b="1" dirty="0">
                 <a:solidFill>
                   <a:srgbClr val="0F172A"/>
                 </a:solidFill>
@@ -5832,7 +6028,7 @@
               <a:t>Languages &amp; Frameworks Used: </a:t>
             </a:r>
             <a:r>
-              <a:rPr sz="1350" b="0">
+              <a:rPr sz="2000" b="0" dirty="0">
                 <a:solidFill>
                   <a:srgbClr val="475569"/>
                 </a:solidFill>
@@ -5845,12 +6041,9 @@
             <a:pPr marL="320040" indent="-320040" algn="l">
               <a:buFont typeface="Arial"/>
               <a:buChar char="•"/>
-              <a:spcAft>
-                <a:spcPts val="1000"/>
-              </a:spcAft>
             </a:pPr>
             <a:r>
-              <a:rPr sz="1350" b="1">
+              <a:rPr sz="2000" b="1" dirty="0">
                 <a:solidFill>
                   <a:srgbClr val="0F172A"/>
                 </a:solidFill>
@@ -5859,7 +6052,7 @@
               <a:t>End-to-End Pipeline Architecture: </a:t>
             </a:r>
             <a:r>
-              <a:rPr sz="1350" b="0">
+              <a:rPr sz="2000" b="0" dirty="0">
                 <a:solidFill>
                   <a:srgbClr val="475569"/>
                 </a:solidFill>
@@ -5879,7 +6072,7 @@
 </file>
 
 <file path=ppt/slides/slide8.xml><?xml version="1.0" encoding="utf-8"?>
-<p:sld xmlns:a="http://schemas.openxmlformats.org/drawingml/2006/main" xmlns:p="http://schemas.openxmlformats.org/presentationml/2006/main" xmlns:r="http://schemas.openxmlformats.org/officeDocument/2006/relationships">
+<p:sld xmlns:a="http://schemas.openxmlformats.org/drawingml/2006/main" xmlns:r="http://schemas.openxmlformats.org/officeDocument/2006/relationships" xmlns:p="http://schemas.openxmlformats.org/presentationml/2006/main">
   <p:cSld>
     <p:bg>
       <p:bgPr>
@@ -5895,7 +6088,14 @@
         <p:cNvGrpSpPr/>
         <p:nvPr/>
       </p:nvGrpSpPr>
-      <p:grpSpPr/>
+      <p:grpSpPr>
+        <a:xfrm>
+          <a:off x="0" y="0"/>
+          <a:ext cx="0" cy="0"/>
+          <a:chOff x="0" y="0"/>
+          <a:chExt cx="0" cy="0"/>
+        </a:xfrm>
+      </p:grpSpPr>
       <p:sp>
         <p:nvSpPr>
           <p:cNvPr id="2" name="TextBox 1"/>
@@ -6020,6 +6220,7 @@
           <a:lstStyle/>
           <a:p>
             <a:pPr algn="ctr"/>
+            <a:endParaRPr/>
           </a:p>
         </p:txBody>
       </p:sp>
@@ -6146,7 +6347,7 @@
         <p:spPr>
           <a:xfrm>
             <a:off x="548640" y="2194560"/>
-            <a:ext cx="11064240" cy="1828800"/>
+            <a:ext cx="11064240" cy="2462213"/>
           </a:xfrm>
           <a:prstGeom prst="rect">
             <a:avLst/>
@@ -6162,12 +6363,9 @@
             <a:pPr marL="320040" indent="-320040" algn="l">
               <a:buFont typeface="Arial"/>
               <a:buChar char="•"/>
-              <a:spcAft>
-                <a:spcPts val="800"/>
-              </a:spcAft>
             </a:pPr>
             <a:r>
-              <a:rPr sz="1350" b="1">
+              <a:rPr sz="2000" b="1" dirty="0">
                 <a:solidFill>
                   <a:srgbClr val="0F172A"/>
                 </a:solidFill>
@@ -6176,7 +6374,7 @@
               <a:t>Feasibility &amp; Risk Mitigation: </a:t>
             </a:r>
             <a:r>
-              <a:rPr sz="1350" b="0">
+              <a:rPr sz="2000" b="0" dirty="0">
                 <a:solidFill>
                   <a:srgbClr val="475569"/>
                 </a:solidFill>
@@ -6189,12 +6387,9 @@
             <a:pPr marL="320040" indent="-320040" algn="l">
               <a:buFont typeface="Arial"/>
               <a:buChar char="•"/>
-              <a:spcAft>
-                <a:spcPts val="800"/>
-              </a:spcAft>
             </a:pPr>
             <a:r>
-              <a:rPr sz="1350" b="1">
+              <a:rPr sz="2000" b="1" dirty="0">
                 <a:solidFill>
                   <a:srgbClr val="0F172A"/>
                 </a:solidFill>
@@ -6203,7 +6398,7 @@
               <a:t>Quantified Operational Impact: </a:t>
             </a:r>
             <a:r>
-              <a:rPr sz="1350" b="0">
+              <a:rPr sz="2000" b="0" dirty="0">
                 <a:solidFill>
                   <a:srgbClr val="475569"/>
                 </a:solidFill>
@@ -6216,12 +6411,9 @@
             <a:pPr marL="320040" indent="-320040" algn="l">
               <a:buFont typeface="Arial"/>
               <a:buChar char="•"/>
-              <a:spcAft>
-                <a:spcPts val="800"/>
-              </a:spcAft>
             </a:pPr>
             <a:r>
-              <a:rPr sz="1350" b="1">
+              <a:rPr sz="2000" b="1" dirty="0">
                 <a:solidFill>
                   <a:srgbClr val="0F172A"/>
                 </a:solidFill>
@@ -6230,7 +6422,7 @@
               <a:t>Immediate Next Steps for Round 2: </a:t>
             </a:r>
             <a:r>
-              <a:rPr sz="1350" b="0">
+              <a:rPr sz="2000" b="0" dirty="0">
                 <a:solidFill>
                   <a:srgbClr val="475569"/>
                 </a:solidFill>

</xml_diff>